<commit_message>
3ª iteración: apps reales capturadas, flujo AI Studio en guías, demos en slides, docs y fixes
- 8 apps construidas en AI Studio y capturadas (2 insignia + 6 demos); capturas de
  flujo (Build, Enable Firebase, emulador) en guias-estudiante/img/ e insertadas en guías;
  placeholders de teléfono Android eliminados; PDFs regenerados con imágenes.
- Slides: slide 'Demo del docente' por sesión + GitHub, glosario GenAI, cómo genera la IA,
  estructura de archivos/personalización manual; contraste MUTED a AA.
- Guías: GitHub/glosario/overview, personalización manual, bitácora de prompts, plantillas.
- Prompts de las 6 demos (prompts-demos-docente.md).
- Nuevos docs: especificacion-asignaciones, material-de-apoyo-links, clase-01-guion-video, plantillas.
- Evaluación: sin defensa; Proyectos=30 sin split por proyecto; quizzes barajados; rúbrica Tareas/Labs.
- Sin 'Plan B' en ningún archivo; terminología unificada a 'Demo del docente'; badges corregidos.
</commit_message>
<xml_diff>
--- a/slides/sesion-02.pptx
+++ b/slides/sesion-02.pptx
@@ -15,6 +15,8 @@
     <p:sldId id="263" r:id="rId14"/>
     <p:sldId id="264" r:id="rId15"/>
     <p:sldId id="265" r:id="rId16"/>
+    <p:sldId id="266" r:id="rId17"/>
+    <p:sldId id="267" r:id="rId18"/>
   </p:sldIdLst>
   <p:sldSz cx="12191695" cy="6858000" type="screen4x3"/>
   <p:notesSz cx="6858000" cy="9144000"/>
@@ -3384,7 +3386,7 @@
             <a:r>
               <a:rPr sz="1500" b="0">
                 <a:solidFill>
-                  <a:srgbClr val="8A7C70"/>
+                  <a:srgbClr val="6F645B"/>
                 </a:solidFill>
                 <a:latin typeface="Calibri"/>
               </a:rPr>
@@ -3434,6 +3436,713 @@
             <a:avLst/>
           </a:prstGeom>
           <a:solidFill>
+            <a:srgbClr val="C84B31"/>
+          </a:solidFill>
+          <a:ln>
+            <a:noFill/>
+          </a:ln>
+          <a:effectLst/>
+        </p:spPr>
+        <p:style>
+          <a:lnRef idx="1">
+            <a:schemeClr val="accent1"/>
+          </a:lnRef>
+          <a:fillRef idx="3">
+            <a:schemeClr val="accent1"/>
+          </a:fillRef>
+          <a:effectRef idx="2">
+            <a:schemeClr val="accent1"/>
+          </a:effectRef>
+          <a:fontRef idx="minor">
+            <a:schemeClr val="lt1"/>
+          </a:fontRef>
+        </p:style>
+        <p:txBody>
+          <a:bodyPr rtlCol="0" anchor="ctr"/>
+          <a:lstStyle/>
+          <a:p>
+            <a:pPr algn="ctr"/>
+          </a:p>
+        </p:txBody>
+      </p:sp>
+      <p:sp>
+        <p:nvSpPr>
+          <p:cNvPr id="3" name="TextBox 2"/>
+          <p:cNvSpPr txBox="1"/>
+          <p:nvPr/>
+        </p:nvSpPr>
+        <p:spPr>
+          <a:xfrm>
+            <a:off x="822960" y="457200"/>
+            <a:ext cx="10515600" cy="457200"/>
+          </a:xfrm>
+          <a:prstGeom prst="rect">
+            <a:avLst/>
+          </a:prstGeom>
+          <a:noFill/>
+        </p:spPr>
+        <p:txBody>
+          <a:bodyPr wrap="square" anchor="t">
+            <a:spAutoFit/>
+          </a:bodyPr>
+          <a:lstStyle/>
+          <a:p>
+            <a:pPr algn="l">
+              <a:spcAft>
+                <a:spcPts val="600"/>
+              </a:spcAft>
+            </a:pPr>
+            <a:r>
+              <a:rPr sz="1800" b="1">
+                <a:solidFill>
+                  <a:srgbClr val="C84B31"/>
+                </a:solidFill>
+                <a:latin typeface="Calibri"/>
+              </a:rPr>
+              <a:t>LO QUE AGREGAMOS HOY</a:t>
+            </a:r>
+          </a:p>
+        </p:txBody>
+      </p:sp>
+      <p:sp>
+        <p:nvSpPr>
+          <p:cNvPr id="4" name="TextBox 3"/>
+          <p:cNvSpPr txBox="1"/>
+          <p:nvPr/>
+        </p:nvSpPr>
+        <p:spPr>
+          <a:xfrm>
+            <a:off x="822960" y="914400"/>
+            <a:ext cx="10607040" cy="1005840"/>
+          </a:xfrm>
+          <a:prstGeom prst="rect">
+            <a:avLst/>
+          </a:prstGeom>
+          <a:noFill/>
+        </p:spPr>
+        <p:txBody>
+          <a:bodyPr wrap="square" anchor="t">
+            <a:spAutoFit/>
+          </a:bodyPr>
+          <a:lstStyle/>
+          <a:p>
+            <a:pPr algn="l">
+              <a:spcAft>
+                <a:spcPts val="600"/>
+              </a:spcAft>
+            </a:pPr>
+            <a:r>
+              <a:rPr sz="3800" b="1">
+                <a:solidFill>
+                  <a:srgbClr val="6D2E46"/>
+                </a:solidFill>
+                <a:latin typeface="Calibri"/>
+              </a:rPr>
+              <a:t>Lista y detalle en Ruta del Café</a:t>
+            </a:r>
+          </a:p>
+        </p:txBody>
+      </p:sp>
+      <p:sp>
+        <p:nvSpPr>
+          <p:cNvPr id="5" name="Rectangle 4"/>
+          <p:cNvSpPr/>
+          <p:nvPr/>
+        </p:nvSpPr>
+        <p:spPr>
+          <a:xfrm>
+            <a:off x="868680" y="1783080"/>
+            <a:ext cx="1554480" cy="64008"/>
+          </a:xfrm>
+          <a:prstGeom prst="rect">
+            <a:avLst/>
+          </a:prstGeom>
+          <a:solidFill>
+            <a:srgbClr val="E3B23C"/>
+          </a:solidFill>
+          <a:ln>
+            <a:noFill/>
+          </a:ln>
+          <a:effectLst/>
+        </p:spPr>
+        <p:style>
+          <a:lnRef idx="1">
+            <a:schemeClr val="accent1"/>
+          </a:lnRef>
+          <a:fillRef idx="3">
+            <a:schemeClr val="accent1"/>
+          </a:fillRef>
+          <a:effectRef idx="2">
+            <a:schemeClr val="accent1"/>
+          </a:effectRef>
+          <a:fontRef idx="minor">
+            <a:schemeClr val="lt1"/>
+          </a:fontRef>
+        </p:style>
+        <p:txBody>
+          <a:bodyPr rtlCol="0" anchor="ctr"/>
+          <a:lstStyle/>
+          <a:p>
+            <a:pPr algn="ctr"/>
+          </a:p>
+        </p:txBody>
+      </p:sp>
+      <p:sp>
+        <p:nvSpPr>
+          <p:cNvPr id="6" name="Rounded Rectangle 5"/>
+          <p:cNvSpPr/>
+          <p:nvPr/>
+        </p:nvSpPr>
+        <p:spPr>
+          <a:xfrm>
+            <a:off x="3657801" y="1956816"/>
+            <a:ext cx="1989990" cy="4178808"/>
+          </a:xfrm>
+          <a:prstGeom prst="roundRect">
+            <a:avLst/>
+          </a:prstGeom>
+          <a:solidFill>
+            <a:srgbClr val="FFFFFF"/>
+          </a:solidFill>
+          <a:ln w="15240">
+            <a:solidFill>
+              <a:srgbClr val="6D2E46"/>
+            </a:solidFill>
+          </a:ln>
+          <a:effectLst/>
+        </p:spPr>
+        <p:style>
+          <a:lnRef idx="1">
+            <a:schemeClr val="accent1"/>
+          </a:lnRef>
+          <a:fillRef idx="3">
+            <a:schemeClr val="accent1"/>
+          </a:fillRef>
+          <a:effectRef idx="2">
+            <a:schemeClr val="accent1"/>
+          </a:effectRef>
+          <a:fontRef idx="minor">
+            <a:schemeClr val="lt1"/>
+          </a:fontRef>
+        </p:style>
+        <p:txBody>
+          <a:bodyPr rtlCol="0" anchor="ctr"/>
+          <a:lstStyle/>
+          <a:p>
+            <a:pPr algn="ctr"/>
+          </a:p>
+        </p:txBody>
+      </p:sp>
+      <p:pic>
+        <p:nvPicPr>
+          <p:cNvPr id="7" name="Picture 6" descr="ruta-home.png"/>
+          <p:cNvPicPr>
+            <a:picLocks noChangeAspect="1"/>
+          </p:cNvPicPr>
+          <p:nvPr/>
+        </p:nvPicPr>
+        <p:blipFill>
+          <a:blip r:embed="rId2"/>
+          <a:stretch>
+            <a:fillRect/>
+          </a:stretch>
+        </p:blipFill>
+        <p:spPr>
+          <a:xfrm>
+            <a:off x="3712665" y="2011680"/>
+            <a:ext cx="1880262" cy="4069080"/>
+          </a:xfrm>
+          <a:prstGeom prst="rect">
+            <a:avLst/>
+          </a:prstGeom>
+        </p:spPr>
+      </p:pic>
+      <p:sp>
+        <p:nvSpPr>
+          <p:cNvPr id="8" name="TextBox 7"/>
+          <p:cNvSpPr txBox="1"/>
+          <p:nvPr/>
+        </p:nvSpPr>
+        <p:spPr>
+          <a:xfrm>
+            <a:off x="2889705" y="6208776"/>
+            <a:ext cx="3526182" cy="457200"/>
+          </a:xfrm>
+          <a:prstGeom prst="rect">
+            <a:avLst/>
+          </a:prstGeom>
+          <a:noFill/>
+        </p:spPr>
+        <p:txBody>
+          <a:bodyPr wrap="square" anchor="t">
+            <a:spAutoFit/>
+          </a:bodyPr>
+          <a:lstStyle/>
+          <a:p>
+            <a:pPr algn="ctr">
+              <a:spcAft>
+                <a:spcPts val="600"/>
+              </a:spcAft>
+            </a:pPr>
+            <a:r>
+              <a:rPr sz="1300" b="1">
+                <a:solidFill>
+                  <a:srgbClr val="6D2E46"/>
+                </a:solidFill>
+                <a:latin typeface="Calibri"/>
+              </a:rPr>
+              <a:t>Lista con filtro</a:t>
+            </a:r>
+          </a:p>
+        </p:txBody>
+      </p:sp>
+      <p:sp>
+        <p:nvSpPr>
+          <p:cNvPr id="9" name="Rounded Rectangle 8"/>
+          <p:cNvSpPr/>
+          <p:nvPr/>
+        </p:nvSpPr>
+        <p:spPr>
+          <a:xfrm>
+            <a:off x="6543903" y="1956816"/>
+            <a:ext cx="1989990" cy="4178808"/>
+          </a:xfrm>
+          <a:prstGeom prst="roundRect">
+            <a:avLst/>
+          </a:prstGeom>
+          <a:solidFill>
+            <a:srgbClr val="FFFFFF"/>
+          </a:solidFill>
+          <a:ln w="15240">
+            <a:solidFill>
+              <a:srgbClr val="6D2E46"/>
+            </a:solidFill>
+          </a:ln>
+          <a:effectLst/>
+        </p:spPr>
+        <p:style>
+          <a:lnRef idx="1">
+            <a:schemeClr val="accent1"/>
+          </a:lnRef>
+          <a:fillRef idx="3">
+            <a:schemeClr val="accent1"/>
+          </a:fillRef>
+          <a:effectRef idx="2">
+            <a:schemeClr val="accent1"/>
+          </a:effectRef>
+          <a:fontRef idx="minor">
+            <a:schemeClr val="lt1"/>
+          </a:fontRef>
+        </p:style>
+        <p:txBody>
+          <a:bodyPr rtlCol="0" anchor="ctr"/>
+          <a:lstStyle/>
+          <a:p>
+            <a:pPr algn="ctr"/>
+          </a:p>
+        </p:txBody>
+      </p:sp>
+      <p:pic>
+        <p:nvPicPr>
+          <p:cNvPr id="10" name="Picture 9" descr="ruta-detalle.png"/>
+          <p:cNvPicPr>
+            <a:picLocks noChangeAspect="1"/>
+          </p:cNvPicPr>
+          <p:nvPr/>
+        </p:nvPicPr>
+        <p:blipFill>
+          <a:blip r:embed="rId3"/>
+          <a:stretch>
+            <a:fillRect/>
+          </a:stretch>
+        </p:blipFill>
+        <p:spPr>
+          <a:xfrm>
+            <a:off x="6598767" y="2011680"/>
+            <a:ext cx="1880262" cy="4069080"/>
+          </a:xfrm>
+          <a:prstGeom prst="rect">
+            <a:avLst/>
+          </a:prstGeom>
+        </p:spPr>
+      </p:pic>
+      <p:sp>
+        <p:nvSpPr>
+          <p:cNvPr id="11" name="TextBox 10"/>
+          <p:cNvSpPr txBox="1"/>
+          <p:nvPr/>
+        </p:nvSpPr>
+        <p:spPr>
+          <a:xfrm>
+            <a:off x="5775807" y="6208776"/>
+            <a:ext cx="3526182" cy="457200"/>
+          </a:xfrm>
+          <a:prstGeom prst="rect">
+            <a:avLst/>
+          </a:prstGeom>
+          <a:noFill/>
+        </p:spPr>
+        <p:txBody>
+          <a:bodyPr wrap="square" anchor="t">
+            <a:spAutoFit/>
+          </a:bodyPr>
+          <a:lstStyle/>
+          <a:p>
+            <a:pPr algn="ctr">
+              <a:spcAft>
+                <a:spcPts val="600"/>
+              </a:spcAft>
+            </a:pPr>
+            <a:r>
+              <a:rPr sz="1300" b="1">
+                <a:solidFill>
+                  <a:srgbClr val="6D2E46"/>
+                </a:solidFill>
+                <a:latin typeface="Calibri"/>
+              </a:rPr>
+              <a:t>Vista de detalle</a:t>
+            </a:r>
+          </a:p>
+        </p:txBody>
+      </p:sp>
+    </p:spTree>
+  </p:cSld>
+  <p:clrMapOvr>
+    <a:masterClrMapping/>
+  </p:clrMapOvr>
+</p:sld>
+</file>
+
+<file path=ppt/slides/slide11.xml><?xml version="1.0" encoding="utf-8"?>
+<p:sld xmlns:a="http://schemas.openxmlformats.org/drawingml/2006/main" xmlns:p="http://schemas.openxmlformats.org/presentationml/2006/main" xmlns:r="http://schemas.openxmlformats.org/officeDocument/2006/relationships">
+  <p:cSld>
+    <p:bg>
+      <p:bgPr>
+        <a:solidFill>
+          <a:srgbClr val="FDF6EC"/>
+        </a:solidFill>
+        <a:effectLst/>
+      </p:bgPr>
+    </p:bg>
+    <p:spTree>
+      <p:nvGrpSpPr>
+        <p:cNvPr id="1" name=""/>
+        <p:cNvGrpSpPr/>
+        <p:nvPr/>
+      </p:nvGrpSpPr>
+      <p:grpSpPr/>
+      <p:sp>
+        <p:nvSpPr>
+          <p:cNvPr id="2" name="Rounded Rectangle 1"/>
+          <p:cNvSpPr/>
+          <p:nvPr/>
+        </p:nvSpPr>
+        <p:spPr>
+          <a:xfrm>
+            <a:off x="640080" y="640080"/>
+            <a:ext cx="10908792" cy="5577840"/>
+          </a:xfrm>
+          <a:prstGeom prst="roundRect">
+            <a:avLst/>
+          </a:prstGeom>
+          <a:solidFill>
+            <a:srgbClr val="FFFFFF"/>
+          </a:solidFill>
+          <a:ln w="15240">
+            <a:solidFill>
+              <a:srgbClr val="EADDC8"/>
+            </a:solidFill>
+          </a:ln>
+          <a:effectLst/>
+        </p:spPr>
+        <p:style>
+          <a:lnRef idx="1">
+            <a:schemeClr val="accent1"/>
+          </a:lnRef>
+          <a:fillRef idx="3">
+            <a:schemeClr val="accent1"/>
+          </a:fillRef>
+          <a:effectRef idx="2">
+            <a:schemeClr val="accent1"/>
+          </a:effectRef>
+          <a:fontRef idx="minor">
+            <a:schemeClr val="lt1"/>
+          </a:fontRef>
+        </p:style>
+        <p:txBody>
+          <a:bodyPr rtlCol="0" anchor="ctr"/>
+          <a:lstStyle/>
+          <a:p>
+            <a:pPr algn="ctr"/>
+          </a:p>
+        </p:txBody>
+      </p:sp>
+      <p:sp>
+        <p:nvSpPr>
+          <p:cNvPr id="3" name="Rectangle 2"/>
+          <p:cNvSpPr/>
+          <p:nvPr/>
+        </p:nvSpPr>
+        <p:spPr>
+          <a:xfrm>
+            <a:off x="640080" y="640080"/>
+            <a:ext cx="201168" cy="5577840"/>
+          </a:xfrm>
+          <a:prstGeom prst="rect">
+            <a:avLst/>
+          </a:prstGeom>
+          <a:solidFill>
+            <a:srgbClr val="E3B23C"/>
+          </a:solidFill>
+          <a:ln>
+            <a:noFill/>
+          </a:ln>
+          <a:effectLst/>
+        </p:spPr>
+        <p:style>
+          <a:lnRef idx="1">
+            <a:schemeClr val="accent1"/>
+          </a:lnRef>
+          <a:fillRef idx="3">
+            <a:schemeClr val="accent1"/>
+          </a:fillRef>
+          <a:effectRef idx="2">
+            <a:schemeClr val="accent1"/>
+          </a:effectRef>
+          <a:fontRef idx="minor">
+            <a:schemeClr val="lt1"/>
+          </a:fontRef>
+        </p:style>
+        <p:txBody>
+          <a:bodyPr rtlCol="0" anchor="ctr"/>
+          <a:lstStyle/>
+          <a:p>
+            <a:pPr algn="ctr"/>
+          </a:p>
+        </p:txBody>
+      </p:sp>
+      <p:sp>
+        <p:nvSpPr>
+          <p:cNvPr id="4" name="TextBox 3"/>
+          <p:cNvSpPr txBox="1"/>
+          <p:nvPr/>
+        </p:nvSpPr>
+        <p:spPr>
+          <a:xfrm>
+            <a:off x="1051560" y="960120"/>
+            <a:ext cx="10058400" cy="457200"/>
+          </a:xfrm>
+          <a:prstGeom prst="rect">
+            <a:avLst/>
+          </a:prstGeom>
+          <a:noFill/>
+        </p:spPr>
+        <p:txBody>
+          <a:bodyPr wrap="square" anchor="t">
+            <a:spAutoFit/>
+          </a:bodyPr>
+          <a:lstStyle/>
+          <a:p>
+            <a:pPr algn="l">
+              <a:spcAft>
+                <a:spcPts val="600"/>
+              </a:spcAft>
+            </a:pPr>
+            <a:r>
+              <a:rPr sz="2000" b="1">
+                <a:solidFill>
+                  <a:srgbClr val="C84B31"/>
+                </a:solidFill>
+                <a:latin typeface="Calibri"/>
+              </a:rPr>
+              <a:t>LABORATORIO DE HOY</a:t>
+            </a:r>
+          </a:p>
+        </p:txBody>
+      </p:sp>
+      <p:sp>
+        <p:nvSpPr>
+          <p:cNvPr id="5" name="TextBox 4"/>
+          <p:cNvSpPr txBox="1"/>
+          <p:nvPr/>
+        </p:nvSpPr>
+        <p:spPr>
+          <a:xfrm>
+            <a:off x="1051560" y="1463040"/>
+            <a:ext cx="10058400" cy="914400"/>
+          </a:xfrm>
+          <a:prstGeom prst="rect">
+            <a:avLst/>
+          </a:prstGeom>
+          <a:noFill/>
+        </p:spPr>
+        <p:txBody>
+          <a:bodyPr wrap="square" anchor="t">
+            <a:spAutoFit/>
+          </a:bodyPr>
+          <a:lstStyle/>
+          <a:p>
+            <a:pPr algn="l">
+              <a:spcAft>
+                <a:spcPts val="600"/>
+              </a:spcAft>
+            </a:pPr>
+            <a:r>
+              <a:rPr sz="3400" b="1">
+                <a:solidFill>
+                  <a:srgbClr val="6D2E46"/>
+                </a:solidFill>
+                <a:latin typeface="Calibri"/>
+              </a:rPr>
+              <a:t>Laboratorio 2 — Prototipo navegable</a:t>
+            </a:r>
+          </a:p>
+        </p:txBody>
+      </p:sp>
+      <p:sp>
+        <p:nvSpPr>
+          <p:cNvPr id="6" name="TextBox 5"/>
+          <p:cNvSpPr txBox="1"/>
+          <p:nvPr/>
+        </p:nvSpPr>
+        <p:spPr>
+          <a:xfrm>
+            <a:off x="1097280" y="2606040"/>
+            <a:ext cx="9875520" cy="3383280"/>
+          </a:xfrm>
+          <a:prstGeom prst="rect">
+            <a:avLst/>
+          </a:prstGeom>
+          <a:noFill/>
+        </p:spPr>
+        <p:txBody>
+          <a:bodyPr wrap="square">
+            <a:spAutoFit/>
+          </a:bodyPr>
+          <a:lstStyle/>
+          <a:p>
+            <a:pPr>
+              <a:spcAft>
+                <a:spcPts val="1500"/>
+              </a:spcAft>
+            </a:pPr>
+            <a:r>
+              <a:rPr sz="2300">
+                <a:solidFill>
+                  <a:srgbClr val="2B2B2B"/>
+                </a:solidFill>
+                <a:latin typeface="Calibri"/>
+              </a:rPr>
+              <a:t>•  Guarda un checkpoint antes de refinar</a:t>
+            </a:r>
+          </a:p>
+          <a:p>
+            <a:pPr>
+              <a:spcAft>
+                <a:spcPts val="1500"/>
+              </a:spcAft>
+            </a:pPr>
+            <a:r>
+              <a:rPr sz="2300">
+                <a:solidFill>
+                  <a:srgbClr val="2B2B2B"/>
+                </a:solidFill>
+                <a:latin typeface="Calibri"/>
+              </a:rPr>
+              <a:t>•  Agrega el filtro por categoría (con "Todas")</a:t>
+            </a:r>
+          </a:p>
+          <a:p>
+            <a:pPr>
+              <a:spcAft>
+                <a:spcPts val="1500"/>
+              </a:spcAft>
+            </a:pPr>
+            <a:r>
+              <a:rPr sz="2300">
+                <a:solidFill>
+                  <a:srgbClr val="2B2B2B"/>
+                </a:solidFill>
+                <a:latin typeface="Calibri"/>
+              </a:rPr>
+              <a:t>•  Agrega la vista de detalle con botón "Volver"</a:t>
+            </a:r>
+          </a:p>
+          <a:p>
+            <a:pPr>
+              <a:spcAft>
+                <a:spcPts val="1500"/>
+              </a:spcAft>
+            </a:pPr>
+            <a:r>
+              <a:rPr sz="2300">
+                <a:solidFill>
+                  <a:srgbClr val="2B2B2B"/>
+                </a:solidFill>
+                <a:latin typeface="Calibri"/>
+              </a:rPr>
+              <a:t>•  Aplica tu propia identidad visual (Tarea 2)</a:t>
+            </a:r>
+          </a:p>
+          <a:p>
+            <a:pPr>
+              <a:spcAft>
+                <a:spcPts val="1500"/>
+              </a:spcAft>
+            </a:pPr>
+            <a:r>
+              <a:rPr sz="2300">
+                <a:solidFill>
+                  <a:srgbClr val="2B2B2B"/>
+                </a:solidFill>
+                <a:latin typeface="Calibri"/>
+              </a:rPr>
+              <a:t>•  Pule un detalle con el modo de anotación</a:t>
+            </a:r>
+          </a:p>
+        </p:txBody>
+      </p:sp>
+    </p:spTree>
+  </p:cSld>
+  <p:clrMapOvr>
+    <a:masterClrMapping/>
+  </p:clrMapOvr>
+</p:sld>
+</file>
+
+<file path=ppt/slides/slide12.xml><?xml version="1.0" encoding="utf-8"?>
+<p:sld xmlns:a="http://schemas.openxmlformats.org/drawingml/2006/main" xmlns:p="http://schemas.openxmlformats.org/presentationml/2006/main" xmlns:r="http://schemas.openxmlformats.org/officeDocument/2006/relationships">
+  <p:cSld>
+    <p:bg>
+      <p:bgPr>
+        <a:solidFill>
+          <a:srgbClr val="FDF6EC"/>
+        </a:solidFill>
+        <a:effectLst/>
+      </p:bgPr>
+    </p:bg>
+    <p:spTree>
+      <p:nvGrpSpPr>
+        <p:cNvPr id="1" name=""/>
+        <p:cNvGrpSpPr/>
+        <p:nvPr/>
+      </p:nvGrpSpPr>
+      <p:grpSpPr/>
+      <p:sp>
+        <p:nvSpPr>
+          <p:cNvPr id="2" name="Rectangle 1"/>
+          <p:cNvSpPr/>
+          <p:nvPr/>
+        </p:nvSpPr>
+        <p:spPr>
+          <a:xfrm>
+            <a:off x="0" y="0"/>
+            <a:ext cx="12191695" cy="146304"/>
+          </a:xfrm>
+          <a:prstGeom prst="rect">
+            <a:avLst/>
+          </a:prstGeom>
+          <a:solidFill>
             <a:srgbClr val="6D2E46"/>
           </a:solidFill>
           <a:ln>
@@ -5361,7 +6070,7 @@
             <a:avLst/>
           </a:prstGeom>
           <a:solidFill>
-            <a:srgbClr val="4F772D"/>
+            <a:srgbClr val="C84B31"/>
           </a:solidFill>
           <a:ln>
             <a:noFill/>
@@ -5424,7 +6133,7 @@
                 </a:solidFill>
                 <a:latin typeface="Calibri"/>
               </a:rPr>
-              <a:t>LISTA → DETALLE → VOLVER</a:t>
+              <a:t>VOCABULARIO DE DISEÑO, NO PROGRAMACIÓN</a:t>
             </a:r>
           </a:p>
         </p:txBody>
@@ -5463,7 +6172,7 @@
                 </a:solidFill>
                 <a:latin typeface="Calibri"/>
               </a:rPr>
-              <a:t>La navegación de un prototipo</a:t>
+              <a:t>Dónde viven los colores y estilos (PWA)</a:t>
             </a:r>
           </a:p>
         </p:txBody>
@@ -5514,104 +6223,14 @@
       </p:sp>
       <p:sp>
         <p:nvSpPr>
-          <p:cNvPr id="6" name="Rounded Rectangle 5"/>
-          <p:cNvSpPr/>
-          <p:nvPr/>
-        </p:nvSpPr>
-        <p:spPr>
-          <a:xfrm>
-            <a:off x="822960" y="3017520"/>
-            <a:ext cx="2274570" cy="1920240"/>
-          </a:xfrm>
-          <a:prstGeom prst="roundRect">
-            <a:avLst/>
-          </a:prstGeom>
-          <a:solidFill>
-            <a:srgbClr val="FFFFFF"/>
-          </a:solidFill>
-          <a:ln w="15240">
-            <a:solidFill>
-              <a:srgbClr val="EADDC8"/>
-            </a:solidFill>
-          </a:ln>
-          <a:effectLst/>
-        </p:spPr>
-        <p:style>
-          <a:lnRef idx="1">
-            <a:schemeClr val="accent1"/>
-          </a:lnRef>
-          <a:fillRef idx="3">
-            <a:schemeClr val="accent1"/>
-          </a:fillRef>
-          <a:effectRef idx="2">
-            <a:schemeClr val="accent1"/>
-          </a:effectRef>
-          <a:fontRef idx="minor">
-            <a:schemeClr val="lt1"/>
-          </a:fontRef>
-        </p:style>
-        <p:txBody>
-          <a:bodyPr rtlCol="0" anchor="ctr"/>
-          <a:lstStyle/>
-          <a:p>
-            <a:pPr algn="ctr"/>
-          </a:p>
-        </p:txBody>
-      </p:sp>
-      <p:sp>
-        <p:nvSpPr>
-          <p:cNvPr id="7" name="Rectangle 6"/>
-          <p:cNvSpPr/>
-          <p:nvPr/>
-        </p:nvSpPr>
-        <p:spPr>
-          <a:xfrm>
-            <a:off x="822960" y="3017520"/>
-            <a:ext cx="2274570" cy="128016"/>
-          </a:xfrm>
-          <a:prstGeom prst="rect">
-            <a:avLst/>
-          </a:prstGeom>
-          <a:solidFill>
-            <a:srgbClr val="6D2E46"/>
-          </a:solidFill>
-          <a:ln>
-            <a:noFill/>
-          </a:ln>
-          <a:effectLst/>
-        </p:spPr>
-        <p:style>
-          <a:lnRef idx="1">
-            <a:schemeClr val="accent1"/>
-          </a:lnRef>
-          <a:fillRef idx="3">
-            <a:schemeClr val="accent1"/>
-          </a:fillRef>
-          <a:effectRef idx="2">
-            <a:schemeClr val="accent1"/>
-          </a:effectRef>
-          <a:fontRef idx="minor">
-            <a:schemeClr val="lt1"/>
-          </a:fontRef>
-        </p:style>
-        <p:txBody>
-          <a:bodyPr rtlCol="0" anchor="ctr"/>
-          <a:lstStyle/>
-          <a:p>
-            <a:pPr algn="ctr"/>
-          </a:p>
-        </p:txBody>
-      </p:sp>
-      <p:sp>
-        <p:nvSpPr>
-          <p:cNvPr id="8" name="TextBox 7"/>
+          <p:cNvPr id="6" name="TextBox 5"/>
           <p:cNvSpPr txBox="1"/>
           <p:nvPr/>
         </p:nvSpPr>
         <p:spPr>
           <a:xfrm>
-            <a:off x="960120" y="3474720"/>
-            <a:ext cx="2000250" cy="1280160"/>
+            <a:off x="896112" y="2103120"/>
+            <a:ext cx="10515600" cy="4480560"/>
           </a:xfrm>
           <a:prstGeom prst="rect">
             <a:avLst/>
@@ -5619,646 +6238,88 @@
           <a:noFill/>
         </p:spPr>
         <p:txBody>
-          <a:bodyPr wrap="square" anchor="ctr">
+          <a:bodyPr wrap="square">
             <a:spAutoFit/>
           </a:bodyPr>
           <a:lstStyle/>
           <a:p>
-            <a:pPr algn="ctr">
-              <a:spcAft>
-                <a:spcPts val="600"/>
-              </a:spcAft>
-            </a:pPr>
-            <a:r>
-              <a:rPr sz="1900" b="1">
-                <a:solidFill>
-                  <a:srgbClr val="6D2E46"/>
-                </a:solidFill>
-                <a:latin typeface="Calibri"/>
-              </a:rPr>
-              <a:t>Lista</a:t>
-            </a:r>
-          </a:p>
-          <a:p>
-            <a:pPr algn="ctr">
-              <a:spcAft>
-                <a:spcPts val="600"/>
-              </a:spcAft>
-            </a:pPr>
-            <a:r>
-              <a:rPr sz="1400" b="0">
-                <a:solidFill>
-                  <a:srgbClr val="8A7C70"/>
-                </a:solidFill>
-                <a:latin typeface="Calibri"/>
-              </a:rPr>
-              <a:t>tarjetas</a:t>
-            </a:r>
-          </a:p>
-        </p:txBody>
-      </p:sp>
-      <p:sp>
-        <p:nvSpPr>
-          <p:cNvPr id="9" name="Right Arrow 8"/>
-          <p:cNvSpPr/>
-          <p:nvPr/>
-        </p:nvSpPr>
-        <p:spPr>
-          <a:xfrm>
-            <a:off x="3152394" y="3776472"/>
-            <a:ext cx="393192" cy="402336"/>
-          </a:xfrm>
-          <a:prstGeom prst="rightArrow">
-            <a:avLst/>
-          </a:prstGeom>
-          <a:solidFill>
-            <a:srgbClr val="E3B23C"/>
-          </a:solidFill>
-          <a:ln>
-            <a:noFill/>
-          </a:ln>
-          <a:effectLst/>
-        </p:spPr>
-        <p:style>
-          <a:lnRef idx="1">
-            <a:schemeClr val="accent1"/>
-          </a:lnRef>
-          <a:fillRef idx="3">
-            <a:schemeClr val="accent1"/>
-          </a:fillRef>
-          <a:effectRef idx="2">
-            <a:schemeClr val="accent1"/>
-          </a:effectRef>
-          <a:fontRef idx="minor">
-            <a:schemeClr val="lt1"/>
-          </a:fontRef>
-        </p:style>
-        <p:txBody>
-          <a:bodyPr rtlCol="0" anchor="ctr"/>
-          <a:lstStyle/>
-          <a:p>
-            <a:pPr algn="ctr"/>
-          </a:p>
-        </p:txBody>
-      </p:sp>
-      <p:sp>
-        <p:nvSpPr>
-          <p:cNvPr id="10" name="Rounded Rectangle 9"/>
-          <p:cNvSpPr/>
-          <p:nvPr/>
-        </p:nvSpPr>
-        <p:spPr>
-          <a:xfrm>
-            <a:off x="3600450" y="3017520"/>
-            <a:ext cx="2274570" cy="1920240"/>
-          </a:xfrm>
-          <a:prstGeom prst="roundRect">
-            <a:avLst/>
-          </a:prstGeom>
-          <a:solidFill>
-            <a:srgbClr val="FFFFFF"/>
-          </a:solidFill>
-          <a:ln w="15240">
-            <a:solidFill>
-              <a:srgbClr val="EADDC8"/>
-            </a:solidFill>
-          </a:ln>
-          <a:effectLst/>
-        </p:spPr>
-        <p:style>
-          <a:lnRef idx="1">
-            <a:schemeClr val="accent1"/>
-          </a:lnRef>
-          <a:fillRef idx="3">
-            <a:schemeClr val="accent1"/>
-          </a:fillRef>
-          <a:effectRef idx="2">
-            <a:schemeClr val="accent1"/>
-          </a:effectRef>
-          <a:fontRef idx="minor">
-            <a:schemeClr val="lt1"/>
-          </a:fontRef>
-        </p:style>
-        <p:txBody>
-          <a:bodyPr rtlCol="0" anchor="ctr"/>
-          <a:lstStyle/>
-          <a:p>
-            <a:pPr algn="ctr"/>
-          </a:p>
-        </p:txBody>
-      </p:sp>
-      <p:sp>
-        <p:nvSpPr>
-          <p:cNvPr id="11" name="Rectangle 10"/>
-          <p:cNvSpPr/>
-          <p:nvPr/>
-        </p:nvSpPr>
-        <p:spPr>
-          <a:xfrm>
-            <a:off x="3600450" y="3017520"/>
-            <a:ext cx="2274570" cy="128016"/>
-          </a:xfrm>
-          <a:prstGeom prst="rect">
-            <a:avLst/>
-          </a:prstGeom>
-          <a:solidFill>
-            <a:srgbClr val="C84B31"/>
-          </a:solidFill>
-          <a:ln>
-            <a:noFill/>
-          </a:ln>
-          <a:effectLst/>
-        </p:spPr>
-        <p:style>
-          <a:lnRef idx="1">
-            <a:schemeClr val="accent1"/>
-          </a:lnRef>
-          <a:fillRef idx="3">
-            <a:schemeClr val="accent1"/>
-          </a:fillRef>
-          <a:effectRef idx="2">
-            <a:schemeClr val="accent1"/>
-          </a:effectRef>
-          <a:fontRef idx="minor">
-            <a:schemeClr val="lt1"/>
-          </a:fontRef>
-        </p:style>
-        <p:txBody>
-          <a:bodyPr rtlCol="0" anchor="ctr"/>
-          <a:lstStyle/>
-          <a:p>
-            <a:pPr algn="ctr"/>
-          </a:p>
-        </p:txBody>
-      </p:sp>
-      <p:sp>
-        <p:nvSpPr>
-          <p:cNvPr id="12" name="TextBox 11"/>
-          <p:cNvSpPr txBox="1"/>
-          <p:nvPr/>
-        </p:nvSpPr>
-        <p:spPr>
-          <a:xfrm>
-            <a:off x="3737610" y="3474720"/>
-            <a:ext cx="2000250" cy="1280160"/>
-          </a:xfrm>
-          <a:prstGeom prst="rect">
-            <a:avLst/>
-          </a:prstGeom>
-          <a:noFill/>
-        </p:spPr>
-        <p:txBody>
-          <a:bodyPr wrap="square" anchor="ctr">
-            <a:spAutoFit/>
-          </a:bodyPr>
-          <a:lstStyle/>
-          <a:p>
-            <a:pPr algn="ctr">
-              <a:spcAft>
-                <a:spcPts val="600"/>
-              </a:spcAft>
-            </a:pPr>
-            <a:r>
-              <a:rPr sz="1900" b="1">
-                <a:solidFill>
-                  <a:srgbClr val="6D2E46"/>
-                </a:solidFill>
-                <a:latin typeface="Calibri"/>
-              </a:rPr>
-              <a:t>Tocar</a:t>
-            </a:r>
-          </a:p>
-          <a:p>
-            <a:pPr algn="ctr">
-              <a:spcAft>
-                <a:spcPts val="600"/>
-              </a:spcAft>
-            </a:pPr>
-            <a:r>
-              <a:rPr sz="1400" b="0">
-                <a:solidFill>
-                  <a:srgbClr val="8A7C70"/>
-                </a:solidFill>
-                <a:latin typeface="Calibri"/>
-              </a:rPr>
-              <a:t>una tarjeta</a:t>
-            </a:r>
-          </a:p>
-        </p:txBody>
-      </p:sp>
-      <p:sp>
-        <p:nvSpPr>
-          <p:cNvPr id="13" name="Right Arrow 12"/>
-          <p:cNvSpPr/>
-          <p:nvPr/>
-        </p:nvSpPr>
-        <p:spPr>
-          <a:xfrm>
-            <a:off x="5929884" y="3776472"/>
-            <a:ext cx="393192" cy="402336"/>
-          </a:xfrm>
-          <a:prstGeom prst="rightArrow">
-            <a:avLst/>
-          </a:prstGeom>
-          <a:solidFill>
-            <a:srgbClr val="E3B23C"/>
-          </a:solidFill>
-          <a:ln>
-            <a:noFill/>
-          </a:ln>
-          <a:effectLst/>
-        </p:spPr>
-        <p:style>
-          <a:lnRef idx="1">
-            <a:schemeClr val="accent1"/>
-          </a:lnRef>
-          <a:fillRef idx="3">
-            <a:schemeClr val="accent1"/>
-          </a:fillRef>
-          <a:effectRef idx="2">
-            <a:schemeClr val="accent1"/>
-          </a:effectRef>
-          <a:fontRef idx="minor">
-            <a:schemeClr val="lt1"/>
-          </a:fontRef>
-        </p:style>
-        <p:txBody>
-          <a:bodyPr rtlCol="0" anchor="ctr"/>
-          <a:lstStyle/>
-          <a:p>
-            <a:pPr algn="ctr"/>
-          </a:p>
-        </p:txBody>
-      </p:sp>
-      <p:sp>
-        <p:nvSpPr>
-          <p:cNvPr id="14" name="Rounded Rectangle 13"/>
-          <p:cNvSpPr/>
-          <p:nvPr/>
-        </p:nvSpPr>
-        <p:spPr>
-          <a:xfrm>
-            <a:off x="6377940" y="3017520"/>
-            <a:ext cx="2274570" cy="1920240"/>
-          </a:xfrm>
-          <a:prstGeom prst="roundRect">
-            <a:avLst/>
-          </a:prstGeom>
-          <a:solidFill>
-            <a:srgbClr val="FFFFFF"/>
-          </a:solidFill>
-          <a:ln w="15240">
-            <a:solidFill>
-              <a:srgbClr val="EADDC8"/>
-            </a:solidFill>
-          </a:ln>
-          <a:effectLst/>
-        </p:spPr>
-        <p:style>
-          <a:lnRef idx="1">
-            <a:schemeClr val="accent1"/>
-          </a:lnRef>
-          <a:fillRef idx="3">
-            <a:schemeClr val="accent1"/>
-          </a:fillRef>
-          <a:effectRef idx="2">
-            <a:schemeClr val="accent1"/>
-          </a:effectRef>
-          <a:fontRef idx="minor">
-            <a:schemeClr val="lt1"/>
-          </a:fontRef>
-        </p:style>
-        <p:txBody>
-          <a:bodyPr rtlCol="0" anchor="ctr"/>
-          <a:lstStyle/>
-          <a:p>
-            <a:pPr algn="ctr"/>
-          </a:p>
-        </p:txBody>
-      </p:sp>
-      <p:sp>
-        <p:nvSpPr>
-          <p:cNvPr id="15" name="Rectangle 14"/>
-          <p:cNvSpPr/>
-          <p:nvPr/>
-        </p:nvSpPr>
-        <p:spPr>
-          <a:xfrm>
-            <a:off x="6377940" y="3017520"/>
-            <a:ext cx="2274570" cy="128016"/>
-          </a:xfrm>
-          <a:prstGeom prst="rect">
-            <a:avLst/>
-          </a:prstGeom>
-          <a:solidFill>
-            <a:srgbClr val="4F772D"/>
-          </a:solidFill>
-          <a:ln>
-            <a:noFill/>
-          </a:ln>
-          <a:effectLst/>
-        </p:spPr>
-        <p:style>
-          <a:lnRef idx="1">
-            <a:schemeClr val="accent1"/>
-          </a:lnRef>
-          <a:fillRef idx="3">
-            <a:schemeClr val="accent1"/>
-          </a:fillRef>
-          <a:effectRef idx="2">
-            <a:schemeClr val="accent1"/>
-          </a:effectRef>
-          <a:fontRef idx="minor">
-            <a:schemeClr val="lt1"/>
-          </a:fontRef>
-        </p:style>
-        <p:txBody>
-          <a:bodyPr rtlCol="0" anchor="ctr"/>
-          <a:lstStyle/>
-          <a:p>
-            <a:pPr algn="ctr"/>
-          </a:p>
-        </p:txBody>
-      </p:sp>
-      <p:sp>
-        <p:nvSpPr>
-          <p:cNvPr id="16" name="TextBox 15"/>
-          <p:cNvSpPr txBox="1"/>
-          <p:nvPr/>
-        </p:nvSpPr>
-        <p:spPr>
-          <a:xfrm>
-            <a:off x="6515100" y="3474720"/>
-            <a:ext cx="2000250" cy="1280160"/>
-          </a:xfrm>
-          <a:prstGeom prst="rect">
-            <a:avLst/>
-          </a:prstGeom>
-          <a:noFill/>
-        </p:spPr>
-        <p:txBody>
-          <a:bodyPr wrap="square" anchor="ctr">
-            <a:spAutoFit/>
-          </a:bodyPr>
-          <a:lstStyle/>
-          <a:p>
-            <a:pPr algn="ctr">
-              <a:spcAft>
-                <a:spcPts val="600"/>
-              </a:spcAft>
-            </a:pPr>
-            <a:r>
-              <a:rPr sz="1900" b="1">
-                <a:solidFill>
-                  <a:srgbClr val="6D2E46"/>
-                </a:solidFill>
-                <a:latin typeface="Calibri"/>
-              </a:rPr>
-              <a:t>Detalle</a:t>
-            </a:r>
-          </a:p>
-          <a:p>
-            <a:pPr algn="ctr">
-              <a:spcAft>
-                <a:spcPts val="600"/>
-              </a:spcAft>
-            </a:pPr>
-            <a:r>
-              <a:rPr sz="1400" b="0">
-                <a:solidFill>
-                  <a:srgbClr val="8A7C70"/>
-                </a:solidFill>
-                <a:latin typeface="Calibri"/>
-              </a:rPr>
-              <a:t>info completa</a:t>
-            </a:r>
-          </a:p>
-        </p:txBody>
-      </p:sp>
-      <p:sp>
-        <p:nvSpPr>
-          <p:cNvPr id="17" name="Right Arrow 16"/>
-          <p:cNvSpPr/>
-          <p:nvPr/>
-        </p:nvSpPr>
-        <p:spPr>
-          <a:xfrm>
-            <a:off x="8707374" y="3776472"/>
-            <a:ext cx="393192" cy="402336"/>
-          </a:xfrm>
-          <a:prstGeom prst="rightArrow">
-            <a:avLst/>
-          </a:prstGeom>
-          <a:solidFill>
-            <a:srgbClr val="E3B23C"/>
-          </a:solidFill>
-          <a:ln>
-            <a:noFill/>
-          </a:ln>
-          <a:effectLst/>
-        </p:spPr>
-        <p:style>
-          <a:lnRef idx="1">
-            <a:schemeClr val="accent1"/>
-          </a:lnRef>
-          <a:fillRef idx="3">
-            <a:schemeClr val="accent1"/>
-          </a:fillRef>
-          <a:effectRef idx="2">
-            <a:schemeClr val="accent1"/>
-          </a:effectRef>
-          <a:fontRef idx="minor">
-            <a:schemeClr val="lt1"/>
-          </a:fontRef>
-        </p:style>
-        <p:txBody>
-          <a:bodyPr rtlCol="0" anchor="ctr"/>
-          <a:lstStyle/>
-          <a:p>
-            <a:pPr algn="ctr"/>
-          </a:p>
-        </p:txBody>
-      </p:sp>
-      <p:sp>
-        <p:nvSpPr>
-          <p:cNvPr id="18" name="Rounded Rectangle 17"/>
-          <p:cNvSpPr/>
-          <p:nvPr/>
-        </p:nvSpPr>
-        <p:spPr>
-          <a:xfrm>
-            <a:off x="9155430" y="3017520"/>
-            <a:ext cx="2274570" cy="1920240"/>
-          </a:xfrm>
-          <a:prstGeom prst="roundRect">
-            <a:avLst/>
-          </a:prstGeom>
-          <a:solidFill>
-            <a:srgbClr val="FFFFFF"/>
-          </a:solidFill>
-          <a:ln w="15240">
-            <a:solidFill>
-              <a:srgbClr val="EADDC8"/>
-            </a:solidFill>
-          </a:ln>
-          <a:effectLst/>
-        </p:spPr>
-        <p:style>
-          <a:lnRef idx="1">
-            <a:schemeClr val="accent1"/>
-          </a:lnRef>
-          <a:fillRef idx="3">
-            <a:schemeClr val="accent1"/>
-          </a:fillRef>
-          <a:effectRef idx="2">
-            <a:schemeClr val="accent1"/>
-          </a:effectRef>
-          <a:fontRef idx="minor">
-            <a:schemeClr val="lt1"/>
-          </a:fontRef>
-        </p:style>
-        <p:txBody>
-          <a:bodyPr rtlCol="0" anchor="ctr"/>
-          <a:lstStyle/>
-          <a:p>
-            <a:pPr algn="ctr"/>
-          </a:p>
-        </p:txBody>
-      </p:sp>
-      <p:sp>
-        <p:nvSpPr>
-          <p:cNvPr id="19" name="Rectangle 18"/>
-          <p:cNvSpPr/>
-          <p:nvPr/>
-        </p:nvSpPr>
-        <p:spPr>
-          <a:xfrm>
-            <a:off x="9155430" y="3017520"/>
-            <a:ext cx="2274570" cy="128016"/>
-          </a:xfrm>
-          <a:prstGeom prst="rect">
-            <a:avLst/>
-          </a:prstGeom>
-          <a:solidFill>
-            <a:srgbClr val="3A6B7E"/>
-          </a:solidFill>
-          <a:ln>
-            <a:noFill/>
-          </a:ln>
-          <a:effectLst/>
-        </p:spPr>
-        <p:style>
-          <a:lnRef idx="1">
-            <a:schemeClr val="accent1"/>
-          </a:lnRef>
-          <a:fillRef idx="3">
-            <a:schemeClr val="accent1"/>
-          </a:fillRef>
-          <a:effectRef idx="2">
-            <a:schemeClr val="accent1"/>
-          </a:effectRef>
-          <a:fontRef idx="minor">
-            <a:schemeClr val="lt1"/>
-          </a:fontRef>
-        </p:style>
-        <p:txBody>
-          <a:bodyPr rtlCol="0" anchor="ctr"/>
-          <a:lstStyle/>
-          <a:p>
-            <a:pPr algn="ctr"/>
-          </a:p>
-        </p:txBody>
-      </p:sp>
-      <p:sp>
-        <p:nvSpPr>
-          <p:cNvPr id="20" name="TextBox 19"/>
-          <p:cNvSpPr txBox="1"/>
-          <p:nvPr/>
-        </p:nvSpPr>
-        <p:spPr>
-          <a:xfrm>
-            <a:off x="9292590" y="3474720"/>
-            <a:ext cx="2000250" cy="1280160"/>
-          </a:xfrm>
-          <a:prstGeom prst="rect">
-            <a:avLst/>
-          </a:prstGeom>
-          <a:noFill/>
-        </p:spPr>
-        <p:txBody>
-          <a:bodyPr wrap="square" anchor="ctr">
-            <a:spAutoFit/>
-          </a:bodyPr>
-          <a:lstStyle/>
-          <a:p>
-            <a:pPr algn="ctr">
-              <a:spcAft>
-                <a:spcPts val="600"/>
-              </a:spcAft>
-            </a:pPr>
-            <a:r>
-              <a:rPr sz="1900" b="1">
-                <a:solidFill>
-                  <a:srgbClr val="6D2E46"/>
-                </a:solidFill>
-                <a:latin typeface="Calibri"/>
-              </a:rPr>
-              <a:t>Volver</a:t>
-            </a:r>
-          </a:p>
-          <a:p>
-            <a:pPr algn="ctr">
-              <a:spcAft>
-                <a:spcPts val="600"/>
-              </a:spcAft>
-            </a:pPr>
-            <a:r>
-              <a:rPr sz="1400" b="0">
-                <a:solidFill>
-                  <a:srgbClr val="8A7C70"/>
-                </a:solidFill>
-                <a:latin typeface="Calibri"/>
-              </a:rPr>
-              <a:t>a la lista</a:t>
-            </a:r>
-          </a:p>
-        </p:txBody>
-      </p:sp>
-      <p:sp>
-        <p:nvSpPr>
-          <p:cNvPr id="21" name="TextBox 20"/>
-          <p:cNvSpPr txBox="1"/>
-          <p:nvPr/>
-        </p:nvSpPr>
-        <p:spPr>
-          <a:xfrm>
-            <a:off x="868680" y="5394960"/>
-            <a:ext cx="10424160" cy="731520"/>
-          </a:xfrm>
-          <a:prstGeom prst="rect">
-            <a:avLst/>
-          </a:prstGeom>
-          <a:noFill/>
-        </p:spPr>
-        <p:txBody>
-          <a:bodyPr wrap="square" anchor="t">
-            <a:spAutoFit/>
-          </a:bodyPr>
-          <a:lstStyle/>
-          <a:p>
-            <a:pPr algn="l">
-              <a:spcAft>
-                <a:spcPts val="600"/>
-              </a:spcAft>
-            </a:pPr>
-            <a:r>
-              <a:rPr sz="1700" b="0">
+            <a:pPr>
+              <a:spcAft>
+                <a:spcPts val="1500"/>
+              </a:spcAft>
+            </a:pPr>
+            <a:r>
+              <a:rPr sz="2300">
                 <a:solidFill>
                   <a:srgbClr val="2B2B2B"/>
                 </a:solidFill>
                 <a:latin typeface="Calibri"/>
               </a:rPr>
-              <a:t>Este mismo patrón lo usarás en casi todas las apps: una pantalla que muestra muchos elementos y otra que muestra uno a fondo.</a:t>
+              <a:t>•  La pestaña Code muestra los archivos que generó la IA; no hay que escribirlos, solo saber leerlos</a:t>
+            </a:r>
+          </a:p>
+          <a:p>
+            <a:pPr>
+              <a:spcAft>
+                <a:spcPts val="1500"/>
+              </a:spcAft>
+            </a:pPr>
+            <a:r>
+              <a:rPr sz="2300">
+                <a:solidFill>
+                  <a:srgbClr val="2B2B2B"/>
+                </a:solidFill>
+                <a:latin typeface="Calibri"/>
+              </a:rPr>
+              <a:t>•  Los colores suelen vivir juntos (config de estilos): ahí cambias la paleta de toda la app</a:t>
+            </a:r>
+          </a:p>
+          <a:p>
+            <a:pPr>
+              <a:spcAft>
+                <a:spcPts val="1500"/>
+              </a:spcAft>
+            </a:pPr>
+            <a:r>
+              <a:rPr sz="2300">
+                <a:solidFill>
+                  <a:srgbClr val="2B2B2B"/>
+                </a:solidFill>
+                <a:latin typeface="Calibri"/>
+              </a:rPr>
+              <a:t>•  La tipografía y los tamaños se definen una vez y se reutilizan: consistencia por diseño</a:t>
+            </a:r>
+          </a:p>
+          <a:p>
+            <a:pPr>
+              <a:spcAft>
+                <a:spcPts val="1500"/>
+              </a:spcAft>
+            </a:pPr>
+            <a:r>
+              <a:rPr sz="2300">
+                <a:solidFill>
+                  <a:srgbClr val="2B2B2B"/>
+                </a:solidFill>
+                <a:latin typeface="Calibri"/>
+              </a:rPr>
+              <a:t>•  Puedes ajustar a mano un valor (por ejemplo un hexadecimal) y ver el cambio en la vista previa</a:t>
+            </a:r>
+          </a:p>
+          <a:p>
+            <a:pPr>
+              <a:spcAft>
+                <a:spcPts val="1500"/>
+              </a:spcAft>
+            </a:pPr>
+            <a:r>
+              <a:rPr sz="2300">
+                <a:solidFill>
+                  <a:srgbClr val="2B2B2B"/>
+                </a:solidFill>
+                <a:latin typeface="Calibri"/>
+              </a:rPr>
+              <a:t>•  Aun así, lo normal es pedir el cambio por prompt; editar a mano es solo para retoques finos</a:t>
             </a:r>
           </a:p>
         </p:txBody>
@@ -6304,7 +6365,7 @@
             <a:avLst/>
           </a:prstGeom>
           <a:solidFill>
-            <a:srgbClr val="C84B31"/>
+            <a:srgbClr val="4F772D"/>
           </a:solidFill>
           <a:ln>
             <a:noFill/>
@@ -6367,7 +6428,7 @@
                 </a:solidFill>
                 <a:latin typeface="Calibri"/>
               </a:rPr>
-              <a:t>LO QUE AGREGAMOS HOY</a:t>
+              <a:t>DEMO DEL DOCENTE · EN VIVO</a:t>
             </a:r>
           </a:p>
         </p:txBody>
@@ -6406,7 +6467,7 @@
                 </a:solidFill>
                 <a:latin typeface="Calibri"/>
               </a:rPr>
-              <a:t>Lista y detalle en Ruta del Café</a:t>
+              <a:t>Adopta un Peludo</a:t>
             </a:r>
           </a:p>
         </p:txBody>
@@ -6463,8 +6524,201 @@
         </p:nvSpPr>
         <p:spPr>
           <a:xfrm>
-            <a:off x="3657801" y="1956816"/>
-            <a:ext cx="1989990" cy="4178808"/>
+            <a:off x="896112" y="2148840"/>
+            <a:ext cx="6583680" cy="566928"/>
+          </a:xfrm>
+          <a:prstGeom prst="roundRect">
+            <a:avLst/>
+          </a:prstGeom>
+          <a:solidFill>
+            <a:srgbClr val="F6ECDD"/>
+          </a:solidFill>
+          <a:ln>
+            <a:noFill/>
+          </a:ln>
+          <a:effectLst/>
+        </p:spPr>
+        <p:style>
+          <a:lnRef idx="1">
+            <a:schemeClr val="accent1"/>
+          </a:lnRef>
+          <a:fillRef idx="3">
+            <a:schemeClr val="accent1"/>
+          </a:fillRef>
+          <a:effectRef idx="2">
+            <a:schemeClr val="accent1"/>
+          </a:effectRef>
+          <a:fontRef idx="minor">
+            <a:schemeClr val="lt1"/>
+          </a:fontRef>
+        </p:style>
+        <p:txBody>
+          <a:bodyPr rtlCol="0" anchor="ctr"/>
+          <a:lstStyle/>
+          <a:p>
+            <a:pPr algn="ctr"/>
+          </a:p>
+        </p:txBody>
+      </p:sp>
+      <p:sp>
+        <p:nvSpPr>
+          <p:cNvPr id="7" name="TextBox 6"/>
+          <p:cNvSpPr txBox="1"/>
+          <p:nvPr/>
+        </p:nvSpPr>
+        <p:spPr>
+          <a:xfrm>
+            <a:off x="1170432" y="2240280"/>
+            <a:ext cx="6035040" cy="457200"/>
+          </a:xfrm>
+          <a:prstGeom prst="rect">
+            <a:avLst/>
+          </a:prstGeom>
+          <a:noFill/>
+        </p:spPr>
+        <p:txBody>
+          <a:bodyPr wrap="square" anchor="ctr">
+            <a:spAutoFit/>
+          </a:bodyPr>
+          <a:lstStyle/>
+          <a:p>
+            <a:pPr algn="l">
+              <a:spcAft>
+                <a:spcPts val="600"/>
+              </a:spcAft>
+            </a:pPr>
+            <a:r>
+              <a:rPr sz="1700" b="1">
+                <a:solidFill>
+                  <a:srgbClr val="6D2E46"/>
+                </a:solidFill>
+                <a:latin typeface="Calibri"/>
+              </a:rPr>
+              <a:t>El docente la construye en vivo — no es tu entrega</a:t>
+            </a:r>
+          </a:p>
+        </p:txBody>
+      </p:sp>
+      <p:sp>
+        <p:nvSpPr>
+          <p:cNvPr id="8" name="TextBox 7"/>
+          <p:cNvSpPr txBox="1"/>
+          <p:nvPr/>
+        </p:nvSpPr>
+        <p:spPr>
+          <a:xfrm>
+            <a:off x="896112" y="2971800"/>
+            <a:ext cx="6583680" cy="2103120"/>
+          </a:xfrm>
+          <a:prstGeom prst="rect">
+            <a:avLst/>
+          </a:prstGeom>
+          <a:noFill/>
+        </p:spPr>
+        <p:txBody>
+          <a:bodyPr wrap="square">
+            <a:spAutoFit/>
+          </a:bodyPr>
+          <a:lstStyle/>
+          <a:p>
+            <a:pPr>
+              <a:spcAft>
+                <a:spcPts val="1400"/>
+              </a:spcAft>
+            </a:pPr>
+            <a:r>
+              <a:rPr sz="2200">
+                <a:solidFill>
+                  <a:srgbClr val="2B2B2B"/>
+                </a:solidFill>
+                <a:latin typeface="Calibri"/>
+              </a:rPr>
+              <a:t>•  Mascotas en adopción, con su ficha de detalle (PWA)</a:t>
+            </a:r>
+          </a:p>
+          <a:p>
+            <a:pPr>
+              <a:spcAft>
+                <a:spcPts val="1400"/>
+              </a:spcAft>
+            </a:pPr>
+            <a:r>
+              <a:rPr sz="2200">
+                <a:solidFill>
+                  <a:srgbClr val="2B2B2B"/>
+                </a:solidFill>
+                <a:latin typeface="Calibri"/>
+              </a:rPr>
+              <a:t>•  Ilustra el flujo lista → detalle → volver y una identidad visual propia</a:t>
+            </a:r>
+          </a:p>
+          <a:p>
+            <a:pPr>
+              <a:spcAft>
+                <a:spcPts val="1400"/>
+              </a:spcAft>
+            </a:pPr>
+            <a:r>
+              <a:rPr sz="2200">
+                <a:solidFill>
+                  <a:srgbClr val="2B2B2B"/>
+                </a:solidFill>
+                <a:latin typeface="Calibri"/>
+              </a:rPr>
+              <a:t>•  El docente la construye y la pule en vivo con el modo de anotación</a:t>
+            </a:r>
+          </a:p>
+        </p:txBody>
+      </p:sp>
+      <p:sp>
+        <p:nvSpPr>
+          <p:cNvPr id="9" name="TextBox 8"/>
+          <p:cNvSpPr txBox="1"/>
+          <p:nvPr/>
+        </p:nvSpPr>
+        <p:spPr>
+          <a:xfrm>
+            <a:off x="896112" y="5257800"/>
+            <a:ext cx="6583680" cy="1188720"/>
+          </a:xfrm>
+          <a:prstGeom prst="rect">
+            <a:avLst/>
+          </a:prstGeom>
+          <a:noFill/>
+        </p:spPr>
+        <p:txBody>
+          <a:bodyPr wrap="square" anchor="t">
+            <a:spAutoFit/>
+          </a:bodyPr>
+          <a:lstStyle/>
+          <a:p>
+            <a:pPr algn="l">
+              <a:spcAft>
+                <a:spcPts val="600"/>
+              </a:spcAft>
+            </a:pPr>
+            <a:r>
+              <a:rPr sz="1500" b="0">
+                <a:solidFill>
+                  <a:srgbClr val="6F645B"/>
+                </a:solidFill>
+                <a:latin typeface="Calibri"/>
+              </a:rPr>
+              <a:t>Ilustra el concepto del día con una app distinta. Tu laboratorio sigue en la app insignia y en tu propia idea.</a:t>
+            </a:r>
+          </a:p>
+        </p:txBody>
+      </p:sp>
+      <p:sp>
+        <p:nvSpPr>
+          <p:cNvPr id="10" name="Rounded Rectangle 9"/>
+          <p:cNvSpPr/>
+          <p:nvPr/>
+        </p:nvSpPr>
+        <p:spPr>
+          <a:xfrm>
+            <a:off x="7772400" y="3202083"/>
+            <a:ext cx="3749040" cy="2099754"/>
           </a:xfrm>
           <a:prstGeom prst="roundRect">
             <a:avLst/>
@@ -6503,7 +6757,7 @@
       </p:sp>
       <p:pic>
         <p:nvPicPr>
-          <p:cNvPr id="7" name="Picture 6" descr="ruta-home.png"/>
+          <p:cNvPr id="11" name="Picture 10" descr="demo-adopta.png"/>
           <p:cNvPicPr>
             <a:picLocks noChangeAspect="1"/>
           </p:cNvPicPr>
@@ -6517,8 +6771,8 @@
         </p:blipFill>
         <p:spPr>
           <a:xfrm>
-            <a:off x="3712665" y="2011680"/>
-            <a:ext cx="1880262" cy="4069080"/>
+            <a:off x="7818120" y="3247803"/>
+            <a:ext cx="3657600" cy="2008314"/>
           </a:xfrm>
           <a:prstGeom prst="rect">
             <a:avLst/>
@@ -6527,14 +6781,14 @@
       </p:pic>
       <p:sp>
         <p:nvSpPr>
-          <p:cNvPr id="8" name="TextBox 7"/>
+          <p:cNvPr id="12" name="TextBox 11"/>
           <p:cNvSpPr txBox="1"/>
           <p:nvPr/>
         </p:nvSpPr>
         <p:spPr>
           <a:xfrm>
-            <a:off x="2889705" y="6208776"/>
-            <a:ext cx="3526182" cy="457200"/>
+            <a:off x="7818120" y="6419088"/>
+            <a:ext cx="3657600" cy="365760"/>
           </a:xfrm>
           <a:prstGeom prst="rect">
             <a:avLst/>
@@ -6553,122 +6807,13 @@
               </a:spcAft>
             </a:pPr>
             <a:r>
-              <a:rPr sz="1300" b="1">
+              <a:rPr sz="1200" b="1">
                 <a:solidFill>
                   <a:srgbClr val="6D2E46"/>
                 </a:solidFill>
                 <a:latin typeface="Calibri"/>
               </a:rPr>
-              <a:t>Lista con filtro</a:t>
-            </a:r>
-          </a:p>
-        </p:txBody>
-      </p:sp>
-      <p:sp>
-        <p:nvSpPr>
-          <p:cNvPr id="9" name="Rounded Rectangle 8"/>
-          <p:cNvSpPr/>
-          <p:nvPr/>
-        </p:nvSpPr>
-        <p:spPr>
-          <a:xfrm>
-            <a:off x="6543903" y="1956816"/>
-            <a:ext cx="1989990" cy="4178808"/>
-          </a:xfrm>
-          <a:prstGeom prst="roundRect">
-            <a:avLst/>
-          </a:prstGeom>
-          <a:solidFill>
-            <a:srgbClr val="FFFFFF"/>
-          </a:solidFill>
-          <a:ln w="15240">
-            <a:solidFill>
-              <a:srgbClr val="6D2E46"/>
-            </a:solidFill>
-          </a:ln>
-          <a:effectLst/>
-        </p:spPr>
-        <p:style>
-          <a:lnRef idx="1">
-            <a:schemeClr val="accent1"/>
-          </a:lnRef>
-          <a:fillRef idx="3">
-            <a:schemeClr val="accent1"/>
-          </a:fillRef>
-          <a:effectRef idx="2">
-            <a:schemeClr val="accent1"/>
-          </a:effectRef>
-          <a:fontRef idx="minor">
-            <a:schemeClr val="lt1"/>
-          </a:fontRef>
-        </p:style>
-        <p:txBody>
-          <a:bodyPr rtlCol="0" anchor="ctr"/>
-          <a:lstStyle/>
-          <a:p>
-            <a:pPr algn="ctr"/>
-          </a:p>
-        </p:txBody>
-      </p:sp>
-      <p:pic>
-        <p:nvPicPr>
-          <p:cNvPr id="10" name="Picture 9" descr="ruta-detalle.png"/>
-          <p:cNvPicPr>
-            <a:picLocks noChangeAspect="1"/>
-          </p:cNvPicPr>
-          <p:nvPr/>
-        </p:nvPicPr>
-        <p:blipFill>
-          <a:blip r:embed="rId3"/>
-          <a:stretch>
-            <a:fillRect/>
-          </a:stretch>
-        </p:blipFill>
-        <p:spPr>
-          <a:xfrm>
-            <a:off x="6598767" y="2011680"/>
-            <a:ext cx="1880262" cy="4069080"/>
-          </a:xfrm>
-          <a:prstGeom prst="rect">
-            <a:avLst/>
-          </a:prstGeom>
-        </p:spPr>
-      </p:pic>
-      <p:sp>
-        <p:nvSpPr>
-          <p:cNvPr id="11" name="TextBox 10"/>
-          <p:cNvSpPr txBox="1"/>
-          <p:nvPr/>
-        </p:nvSpPr>
-        <p:spPr>
-          <a:xfrm>
-            <a:off x="5775807" y="6208776"/>
-            <a:ext cx="3526182" cy="457200"/>
-          </a:xfrm>
-          <a:prstGeom prst="rect">
-            <a:avLst/>
-          </a:prstGeom>
-          <a:noFill/>
-        </p:spPr>
-        <p:txBody>
-          <a:bodyPr wrap="square" anchor="t">
-            <a:spAutoFit/>
-          </a:bodyPr>
-          <a:lstStyle/>
-          <a:p>
-            <a:pPr algn="ctr">
-              <a:spcAft>
-                <a:spcPts val="600"/>
-              </a:spcAft>
-            </a:pPr>
-            <a:r>
-              <a:rPr sz="1300" b="1">
-                <a:solidFill>
-                  <a:srgbClr val="6D2E46"/>
-                </a:solidFill>
-                <a:latin typeface="Calibri"/>
-              </a:rPr>
-              <a:t>Vista de detalle</a:t>
+              <a:t>Captura real de la demo</a:t>
             </a:r>
           </a:p>
         </p:txBody>
@@ -6701,14 +6846,180 @@
       <p:grpSpPr/>
       <p:sp>
         <p:nvSpPr>
-          <p:cNvPr id="2" name="Rounded Rectangle 1"/>
+          <p:cNvPr id="2" name="Rectangle 1"/>
           <p:cNvSpPr/>
           <p:nvPr/>
         </p:nvSpPr>
         <p:spPr>
           <a:xfrm>
-            <a:off x="640080" y="640080"/>
-            <a:ext cx="10908792" cy="5577840"/>
+            <a:off x="0" y="0"/>
+            <a:ext cx="12191695" cy="146304"/>
+          </a:xfrm>
+          <a:prstGeom prst="rect">
+            <a:avLst/>
+          </a:prstGeom>
+          <a:solidFill>
+            <a:srgbClr val="4F772D"/>
+          </a:solidFill>
+          <a:ln>
+            <a:noFill/>
+          </a:ln>
+          <a:effectLst/>
+        </p:spPr>
+        <p:style>
+          <a:lnRef idx="1">
+            <a:schemeClr val="accent1"/>
+          </a:lnRef>
+          <a:fillRef idx="3">
+            <a:schemeClr val="accent1"/>
+          </a:fillRef>
+          <a:effectRef idx="2">
+            <a:schemeClr val="accent1"/>
+          </a:effectRef>
+          <a:fontRef idx="minor">
+            <a:schemeClr val="lt1"/>
+          </a:fontRef>
+        </p:style>
+        <p:txBody>
+          <a:bodyPr rtlCol="0" anchor="ctr"/>
+          <a:lstStyle/>
+          <a:p>
+            <a:pPr algn="ctr"/>
+          </a:p>
+        </p:txBody>
+      </p:sp>
+      <p:sp>
+        <p:nvSpPr>
+          <p:cNvPr id="3" name="TextBox 2"/>
+          <p:cNvSpPr txBox="1"/>
+          <p:nvPr/>
+        </p:nvSpPr>
+        <p:spPr>
+          <a:xfrm>
+            <a:off x="822960" y="457200"/>
+            <a:ext cx="10515600" cy="457200"/>
+          </a:xfrm>
+          <a:prstGeom prst="rect">
+            <a:avLst/>
+          </a:prstGeom>
+          <a:noFill/>
+        </p:spPr>
+        <p:txBody>
+          <a:bodyPr wrap="square" anchor="t">
+            <a:spAutoFit/>
+          </a:bodyPr>
+          <a:lstStyle/>
+          <a:p>
+            <a:pPr algn="l">
+              <a:spcAft>
+                <a:spcPts val="600"/>
+              </a:spcAft>
+            </a:pPr>
+            <a:r>
+              <a:rPr sz="1800" b="1">
+                <a:solidFill>
+                  <a:srgbClr val="C84B31"/>
+                </a:solidFill>
+                <a:latin typeface="Calibri"/>
+              </a:rPr>
+              <a:t>LISTA → DETALLE → VOLVER</a:t>
+            </a:r>
+          </a:p>
+        </p:txBody>
+      </p:sp>
+      <p:sp>
+        <p:nvSpPr>
+          <p:cNvPr id="4" name="TextBox 3"/>
+          <p:cNvSpPr txBox="1"/>
+          <p:nvPr/>
+        </p:nvSpPr>
+        <p:spPr>
+          <a:xfrm>
+            <a:off x="822960" y="914400"/>
+            <a:ext cx="10607040" cy="1005840"/>
+          </a:xfrm>
+          <a:prstGeom prst="rect">
+            <a:avLst/>
+          </a:prstGeom>
+          <a:noFill/>
+        </p:spPr>
+        <p:txBody>
+          <a:bodyPr wrap="square" anchor="t">
+            <a:spAutoFit/>
+          </a:bodyPr>
+          <a:lstStyle/>
+          <a:p>
+            <a:pPr algn="l">
+              <a:spcAft>
+                <a:spcPts val="600"/>
+              </a:spcAft>
+            </a:pPr>
+            <a:r>
+              <a:rPr sz="3800" b="1">
+                <a:solidFill>
+                  <a:srgbClr val="6D2E46"/>
+                </a:solidFill>
+                <a:latin typeface="Calibri"/>
+              </a:rPr>
+              <a:t>La navegación de un prototipo</a:t>
+            </a:r>
+          </a:p>
+        </p:txBody>
+      </p:sp>
+      <p:sp>
+        <p:nvSpPr>
+          <p:cNvPr id="5" name="Rectangle 4"/>
+          <p:cNvSpPr/>
+          <p:nvPr/>
+        </p:nvSpPr>
+        <p:spPr>
+          <a:xfrm>
+            <a:off x="868680" y="1783080"/>
+            <a:ext cx="1554480" cy="64008"/>
+          </a:xfrm>
+          <a:prstGeom prst="rect">
+            <a:avLst/>
+          </a:prstGeom>
+          <a:solidFill>
+            <a:srgbClr val="E3B23C"/>
+          </a:solidFill>
+          <a:ln>
+            <a:noFill/>
+          </a:ln>
+          <a:effectLst/>
+        </p:spPr>
+        <p:style>
+          <a:lnRef idx="1">
+            <a:schemeClr val="accent1"/>
+          </a:lnRef>
+          <a:fillRef idx="3">
+            <a:schemeClr val="accent1"/>
+          </a:fillRef>
+          <a:effectRef idx="2">
+            <a:schemeClr val="accent1"/>
+          </a:effectRef>
+          <a:fontRef idx="minor">
+            <a:schemeClr val="lt1"/>
+          </a:fontRef>
+        </p:style>
+        <p:txBody>
+          <a:bodyPr rtlCol="0" anchor="ctr"/>
+          <a:lstStyle/>
+          <a:p>
+            <a:pPr algn="ctr"/>
+          </a:p>
+        </p:txBody>
+      </p:sp>
+      <p:sp>
+        <p:nvSpPr>
+          <p:cNvPr id="6" name="Rounded Rectangle 5"/>
+          <p:cNvSpPr/>
+          <p:nvPr/>
+        </p:nvSpPr>
+        <p:spPr>
+          <a:xfrm>
+            <a:off x="822960" y="3017520"/>
+            <a:ext cx="2274570" cy="1920240"/>
           </a:xfrm>
           <a:prstGeom prst="roundRect">
             <a:avLst/>
@@ -6747,16 +7058,115 @@
       </p:sp>
       <p:sp>
         <p:nvSpPr>
-          <p:cNvPr id="3" name="Rectangle 2"/>
+          <p:cNvPr id="7" name="Rectangle 6"/>
           <p:cNvSpPr/>
           <p:nvPr/>
         </p:nvSpPr>
         <p:spPr>
           <a:xfrm>
-            <a:off x="640080" y="640080"/>
-            <a:ext cx="201168" cy="5577840"/>
-          </a:xfrm>
-          <a:prstGeom prst="rect">
+            <a:off x="822960" y="3017520"/>
+            <a:ext cx="2274570" cy="128016"/>
+          </a:xfrm>
+          <a:prstGeom prst="rect">
+            <a:avLst/>
+          </a:prstGeom>
+          <a:solidFill>
+            <a:srgbClr val="6D2E46"/>
+          </a:solidFill>
+          <a:ln>
+            <a:noFill/>
+          </a:ln>
+          <a:effectLst/>
+        </p:spPr>
+        <p:style>
+          <a:lnRef idx="1">
+            <a:schemeClr val="accent1"/>
+          </a:lnRef>
+          <a:fillRef idx="3">
+            <a:schemeClr val="accent1"/>
+          </a:fillRef>
+          <a:effectRef idx="2">
+            <a:schemeClr val="accent1"/>
+          </a:effectRef>
+          <a:fontRef idx="minor">
+            <a:schemeClr val="lt1"/>
+          </a:fontRef>
+        </p:style>
+        <p:txBody>
+          <a:bodyPr rtlCol="0" anchor="ctr"/>
+          <a:lstStyle/>
+          <a:p>
+            <a:pPr algn="ctr"/>
+          </a:p>
+        </p:txBody>
+      </p:sp>
+      <p:sp>
+        <p:nvSpPr>
+          <p:cNvPr id="8" name="TextBox 7"/>
+          <p:cNvSpPr txBox="1"/>
+          <p:nvPr/>
+        </p:nvSpPr>
+        <p:spPr>
+          <a:xfrm>
+            <a:off x="960120" y="3474720"/>
+            <a:ext cx="2000250" cy="1280160"/>
+          </a:xfrm>
+          <a:prstGeom prst="rect">
+            <a:avLst/>
+          </a:prstGeom>
+          <a:noFill/>
+        </p:spPr>
+        <p:txBody>
+          <a:bodyPr wrap="square" anchor="ctr">
+            <a:spAutoFit/>
+          </a:bodyPr>
+          <a:lstStyle/>
+          <a:p>
+            <a:pPr algn="ctr">
+              <a:spcAft>
+                <a:spcPts val="600"/>
+              </a:spcAft>
+            </a:pPr>
+            <a:r>
+              <a:rPr sz="1900" b="1">
+                <a:solidFill>
+                  <a:srgbClr val="6D2E46"/>
+                </a:solidFill>
+                <a:latin typeface="Calibri"/>
+              </a:rPr>
+              <a:t>Lista</a:t>
+            </a:r>
+          </a:p>
+          <a:p>
+            <a:pPr algn="ctr">
+              <a:spcAft>
+                <a:spcPts val="600"/>
+              </a:spcAft>
+            </a:pPr>
+            <a:r>
+              <a:rPr sz="1400" b="0">
+                <a:solidFill>
+                  <a:srgbClr val="6F645B"/>
+                </a:solidFill>
+                <a:latin typeface="Calibri"/>
+              </a:rPr>
+              <a:t>tarjetas</a:t>
+            </a:r>
+          </a:p>
+        </p:txBody>
+      </p:sp>
+      <p:sp>
+        <p:nvSpPr>
+          <p:cNvPr id="9" name="Right Arrow 8"/>
+          <p:cNvSpPr/>
+          <p:nvPr/>
+        </p:nvSpPr>
+        <p:spPr>
+          <a:xfrm>
+            <a:off x="3152394" y="3776472"/>
+            <a:ext cx="393192" cy="402336"/>
+          </a:xfrm>
+          <a:prstGeom prst="rightArrow">
             <a:avLst/>
           </a:prstGeom>
           <a:solidFill>
@@ -6791,14 +7201,537 @@
       </p:sp>
       <p:sp>
         <p:nvSpPr>
-          <p:cNvPr id="4" name="TextBox 3"/>
+          <p:cNvPr id="10" name="Rounded Rectangle 9"/>
+          <p:cNvSpPr/>
+          <p:nvPr/>
+        </p:nvSpPr>
+        <p:spPr>
+          <a:xfrm>
+            <a:off x="3600450" y="3017520"/>
+            <a:ext cx="2274570" cy="1920240"/>
+          </a:xfrm>
+          <a:prstGeom prst="roundRect">
+            <a:avLst/>
+          </a:prstGeom>
+          <a:solidFill>
+            <a:srgbClr val="FFFFFF"/>
+          </a:solidFill>
+          <a:ln w="15240">
+            <a:solidFill>
+              <a:srgbClr val="EADDC8"/>
+            </a:solidFill>
+          </a:ln>
+          <a:effectLst/>
+        </p:spPr>
+        <p:style>
+          <a:lnRef idx="1">
+            <a:schemeClr val="accent1"/>
+          </a:lnRef>
+          <a:fillRef idx="3">
+            <a:schemeClr val="accent1"/>
+          </a:fillRef>
+          <a:effectRef idx="2">
+            <a:schemeClr val="accent1"/>
+          </a:effectRef>
+          <a:fontRef idx="minor">
+            <a:schemeClr val="lt1"/>
+          </a:fontRef>
+        </p:style>
+        <p:txBody>
+          <a:bodyPr rtlCol="0" anchor="ctr"/>
+          <a:lstStyle/>
+          <a:p>
+            <a:pPr algn="ctr"/>
+          </a:p>
+        </p:txBody>
+      </p:sp>
+      <p:sp>
+        <p:nvSpPr>
+          <p:cNvPr id="11" name="Rectangle 10"/>
+          <p:cNvSpPr/>
+          <p:nvPr/>
+        </p:nvSpPr>
+        <p:spPr>
+          <a:xfrm>
+            <a:off x="3600450" y="3017520"/>
+            <a:ext cx="2274570" cy="128016"/>
+          </a:xfrm>
+          <a:prstGeom prst="rect">
+            <a:avLst/>
+          </a:prstGeom>
+          <a:solidFill>
+            <a:srgbClr val="C84B31"/>
+          </a:solidFill>
+          <a:ln>
+            <a:noFill/>
+          </a:ln>
+          <a:effectLst/>
+        </p:spPr>
+        <p:style>
+          <a:lnRef idx="1">
+            <a:schemeClr val="accent1"/>
+          </a:lnRef>
+          <a:fillRef idx="3">
+            <a:schemeClr val="accent1"/>
+          </a:fillRef>
+          <a:effectRef idx="2">
+            <a:schemeClr val="accent1"/>
+          </a:effectRef>
+          <a:fontRef idx="minor">
+            <a:schemeClr val="lt1"/>
+          </a:fontRef>
+        </p:style>
+        <p:txBody>
+          <a:bodyPr rtlCol="0" anchor="ctr"/>
+          <a:lstStyle/>
+          <a:p>
+            <a:pPr algn="ctr"/>
+          </a:p>
+        </p:txBody>
+      </p:sp>
+      <p:sp>
+        <p:nvSpPr>
+          <p:cNvPr id="12" name="TextBox 11"/>
           <p:cNvSpPr txBox="1"/>
           <p:nvPr/>
         </p:nvSpPr>
         <p:spPr>
           <a:xfrm>
-            <a:off x="1051560" y="960120"/>
-            <a:ext cx="10058400" cy="457200"/>
+            <a:off x="3737610" y="3474720"/>
+            <a:ext cx="2000250" cy="1280160"/>
+          </a:xfrm>
+          <a:prstGeom prst="rect">
+            <a:avLst/>
+          </a:prstGeom>
+          <a:noFill/>
+        </p:spPr>
+        <p:txBody>
+          <a:bodyPr wrap="square" anchor="ctr">
+            <a:spAutoFit/>
+          </a:bodyPr>
+          <a:lstStyle/>
+          <a:p>
+            <a:pPr algn="ctr">
+              <a:spcAft>
+                <a:spcPts val="600"/>
+              </a:spcAft>
+            </a:pPr>
+            <a:r>
+              <a:rPr sz="1900" b="1">
+                <a:solidFill>
+                  <a:srgbClr val="6D2E46"/>
+                </a:solidFill>
+                <a:latin typeface="Calibri"/>
+              </a:rPr>
+              <a:t>Tocar</a:t>
+            </a:r>
+          </a:p>
+          <a:p>
+            <a:pPr algn="ctr">
+              <a:spcAft>
+                <a:spcPts val="600"/>
+              </a:spcAft>
+            </a:pPr>
+            <a:r>
+              <a:rPr sz="1400" b="0">
+                <a:solidFill>
+                  <a:srgbClr val="6F645B"/>
+                </a:solidFill>
+                <a:latin typeface="Calibri"/>
+              </a:rPr>
+              <a:t>una tarjeta</a:t>
+            </a:r>
+          </a:p>
+        </p:txBody>
+      </p:sp>
+      <p:sp>
+        <p:nvSpPr>
+          <p:cNvPr id="13" name="Right Arrow 12"/>
+          <p:cNvSpPr/>
+          <p:nvPr/>
+        </p:nvSpPr>
+        <p:spPr>
+          <a:xfrm>
+            <a:off x="5929884" y="3776472"/>
+            <a:ext cx="393192" cy="402336"/>
+          </a:xfrm>
+          <a:prstGeom prst="rightArrow">
+            <a:avLst/>
+          </a:prstGeom>
+          <a:solidFill>
+            <a:srgbClr val="E3B23C"/>
+          </a:solidFill>
+          <a:ln>
+            <a:noFill/>
+          </a:ln>
+          <a:effectLst/>
+        </p:spPr>
+        <p:style>
+          <a:lnRef idx="1">
+            <a:schemeClr val="accent1"/>
+          </a:lnRef>
+          <a:fillRef idx="3">
+            <a:schemeClr val="accent1"/>
+          </a:fillRef>
+          <a:effectRef idx="2">
+            <a:schemeClr val="accent1"/>
+          </a:effectRef>
+          <a:fontRef idx="minor">
+            <a:schemeClr val="lt1"/>
+          </a:fontRef>
+        </p:style>
+        <p:txBody>
+          <a:bodyPr rtlCol="0" anchor="ctr"/>
+          <a:lstStyle/>
+          <a:p>
+            <a:pPr algn="ctr"/>
+          </a:p>
+        </p:txBody>
+      </p:sp>
+      <p:sp>
+        <p:nvSpPr>
+          <p:cNvPr id="14" name="Rounded Rectangle 13"/>
+          <p:cNvSpPr/>
+          <p:nvPr/>
+        </p:nvSpPr>
+        <p:spPr>
+          <a:xfrm>
+            <a:off x="6377940" y="3017520"/>
+            <a:ext cx="2274570" cy="1920240"/>
+          </a:xfrm>
+          <a:prstGeom prst="roundRect">
+            <a:avLst/>
+          </a:prstGeom>
+          <a:solidFill>
+            <a:srgbClr val="FFFFFF"/>
+          </a:solidFill>
+          <a:ln w="15240">
+            <a:solidFill>
+              <a:srgbClr val="EADDC8"/>
+            </a:solidFill>
+          </a:ln>
+          <a:effectLst/>
+        </p:spPr>
+        <p:style>
+          <a:lnRef idx="1">
+            <a:schemeClr val="accent1"/>
+          </a:lnRef>
+          <a:fillRef idx="3">
+            <a:schemeClr val="accent1"/>
+          </a:fillRef>
+          <a:effectRef idx="2">
+            <a:schemeClr val="accent1"/>
+          </a:effectRef>
+          <a:fontRef idx="minor">
+            <a:schemeClr val="lt1"/>
+          </a:fontRef>
+        </p:style>
+        <p:txBody>
+          <a:bodyPr rtlCol="0" anchor="ctr"/>
+          <a:lstStyle/>
+          <a:p>
+            <a:pPr algn="ctr"/>
+          </a:p>
+        </p:txBody>
+      </p:sp>
+      <p:sp>
+        <p:nvSpPr>
+          <p:cNvPr id="15" name="Rectangle 14"/>
+          <p:cNvSpPr/>
+          <p:nvPr/>
+        </p:nvSpPr>
+        <p:spPr>
+          <a:xfrm>
+            <a:off x="6377940" y="3017520"/>
+            <a:ext cx="2274570" cy="128016"/>
+          </a:xfrm>
+          <a:prstGeom prst="rect">
+            <a:avLst/>
+          </a:prstGeom>
+          <a:solidFill>
+            <a:srgbClr val="4F772D"/>
+          </a:solidFill>
+          <a:ln>
+            <a:noFill/>
+          </a:ln>
+          <a:effectLst/>
+        </p:spPr>
+        <p:style>
+          <a:lnRef idx="1">
+            <a:schemeClr val="accent1"/>
+          </a:lnRef>
+          <a:fillRef idx="3">
+            <a:schemeClr val="accent1"/>
+          </a:fillRef>
+          <a:effectRef idx="2">
+            <a:schemeClr val="accent1"/>
+          </a:effectRef>
+          <a:fontRef idx="minor">
+            <a:schemeClr val="lt1"/>
+          </a:fontRef>
+        </p:style>
+        <p:txBody>
+          <a:bodyPr rtlCol="0" anchor="ctr"/>
+          <a:lstStyle/>
+          <a:p>
+            <a:pPr algn="ctr"/>
+          </a:p>
+        </p:txBody>
+      </p:sp>
+      <p:sp>
+        <p:nvSpPr>
+          <p:cNvPr id="16" name="TextBox 15"/>
+          <p:cNvSpPr txBox="1"/>
+          <p:nvPr/>
+        </p:nvSpPr>
+        <p:spPr>
+          <a:xfrm>
+            <a:off x="6515100" y="3474720"/>
+            <a:ext cx="2000250" cy="1280160"/>
+          </a:xfrm>
+          <a:prstGeom prst="rect">
+            <a:avLst/>
+          </a:prstGeom>
+          <a:noFill/>
+        </p:spPr>
+        <p:txBody>
+          <a:bodyPr wrap="square" anchor="ctr">
+            <a:spAutoFit/>
+          </a:bodyPr>
+          <a:lstStyle/>
+          <a:p>
+            <a:pPr algn="ctr">
+              <a:spcAft>
+                <a:spcPts val="600"/>
+              </a:spcAft>
+            </a:pPr>
+            <a:r>
+              <a:rPr sz="1900" b="1">
+                <a:solidFill>
+                  <a:srgbClr val="6D2E46"/>
+                </a:solidFill>
+                <a:latin typeface="Calibri"/>
+              </a:rPr>
+              <a:t>Detalle</a:t>
+            </a:r>
+          </a:p>
+          <a:p>
+            <a:pPr algn="ctr">
+              <a:spcAft>
+                <a:spcPts val="600"/>
+              </a:spcAft>
+            </a:pPr>
+            <a:r>
+              <a:rPr sz="1400" b="0">
+                <a:solidFill>
+                  <a:srgbClr val="6F645B"/>
+                </a:solidFill>
+                <a:latin typeface="Calibri"/>
+              </a:rPr>
+              <a:t>info completa</a:t>
+            </a:r>
+          </a:p>
+        </p:txBody>
+      </p:sp>
+      <p:sp>
+        <p:nvSpPr>
+          <p:cNvPr id="17" name="Right Arrow 16"/>
+          <p:cNvSpPr/>
+          <p:nvPr/>
+        </p:nvSpPr>
+        <p:spPr>
+          <a:xfrm>
+            <a:off x="8707374" y="3776472"/>
+            <a:ext cx="393192" cy="402336"/>
+          </a:xfrm>
+          <a:prstGeom prst="rightArrow">
+            <a:avLst/>
+          </a:prstGeom>
+          <a:solidFill>
+            <a:srgbClr val="E3B23C"/>
+          </a:solidFill>
+          <a:ln>
+            <a:noFill/>
+          </a:ln>
+          <a:effectLst/>
+        </p:spPr>
+        <p:style>
+          <a:lnRef idx="1">
+            <a:schemeClr val="accent1"/>
+          </a:lnRef>
+          <a:fillRef idx="3">
+            <a:schemeClr val="accent1"/>
+          </a:fillRef>
+          <a:effectRef idx="2">
+            <a:schemeClr val="accent1"/>
+          </a:effectRef>
+          <a:fontRef idx="minor">
+            <a:schemeClr val="lt1"/>
+          </a:fontRef>
+        </p:style>
+        <p:txBody>
+          <a:bodyPr rtlCol="0" anchor="ctr"/>
+          <a:lstStyle/>
+          <a:p>
+            <a:pPr algn="ctr"/>
+          </a:p>
+        </p:txBody>
+      </p:sp>
+      <p:sp>
+        <p:nvSpPr>
+          <p:cNvPr id="18" name="Rounded Rectangle 17"/>
+          <p:cNvSpPr/>
+          <p:nvPr/>
+        </p:nvSpPr>
+        <p:spPr>
+          <a:xfrm>
+            <a:off x="9155430" y="3017520"/>
+            <a:ext cx="2274570" cy="1920240"/>
+          </a:xfrm>
+          <a:prstGeom prst="roundRect">
+            <a:avLst/>
+          </a:prstGeom>
+          <a:solidFill>
+            <a:srgbClr val="FFFFFF"/>
+          </a:solidFill>
+          <a:ln w="15240">
+            <a:solidFill>
+              <a:srgbClr val="EADDC8"/>
+            </a:solidFill>
+          </a:ln>
+          <a:effectLst/>
+        </p:spPr>
+        <p:style>
+          <a:lnRef idx="1">
+            <a:schemeClr val="accent1"/>
+          </a:lnRef>
+          <a:fillRef idx="3">
+            <a:schemeClr val="accent1"/>
+          </a:fillRef>
+          <a:effectRef idx="2">
+            <a:schemeClr val="accent1"/>
+          </a:effectRef>
+          <a:fontRef idx="minor">
+            <a:schemeClr val="lt1"/>
+          </a:fontRef>
+        </p:style>
+        <p:txBody>
+          <a:bodyPr rtlCol="0" anchor="ctr"/>
+          <a:lstStyle/>
+          <a:p>
+            <a:pPr algn="ctr"/>
+          </a:p>
+        </p:txBody>
+      </p:sp>
+      <p:sp>
+        <p:nvSpPr>
+          <p:cNvPr id="19" name="Rectangle 18"/>
+          <p:cNvSpPr/>
+          <p:nvPr/>
+        </p:nvSpPr>
+        <p:spPr>
+          <a:xfrm>
+            <a:off x="9155430" y="3017520"/>
+            <a:ext cx="2274570" cy="128016"/>
+          </a:xfrm>
+          <a:prstGeom prst="rect">
+            <a:avLst/>
+          </a:prstGeom>
+          <a:solidFill>
+            <a:srgbClr val="3A6B7E"/>
+          </a:solidFill>
+          <a:ln>
+            <a:noFill/>
+          </a:ln>
+          <a:effectLst/>
+        </p:spPr>
+        <p:style>
+          <a:lnRef idx="1">
+            <a:schemeClr val="accent1"/>
+          </a:lnRef>
+          <a:fillRef idx="3">
+            <a:schemeClr val="accent1"/>
+          </a:fillRef>
+          <a:effectRef idx="2">
+            <a:schemeClr val="accent1"/>
+          </a:effectRef>
+          <a:fontRef idx="minor">
+            <a:schemeClr val="lt1"/>
+          </a:fontRef>
+        </p:style>
+        <p:txBody>
+          <a:bodyPr rtlCol="0" anchor="ctr"/>
+          <a:lstStyle/>
+          <a:p>
+            <a:pPr algn="ctr"/>
+          </a:p>
+        </p:txBody>
+      </p:sp>
+      <p:sp>
+        <p:nvSpPr>
+          <p:cNvPr id="20" name="TextBox 19"/>
+          <p:cNvSpPr txBox="1"/>
+          <p:nvPr/>
+        </p:nvSpPr>
+        <p:spPr>
+          <a:xfrm>
+            <a:off x="9292590" y="3474720"/>
+            <a:ext cx="2000250" cy="1280160"/>
+          </a:xfrm>
+          <a:prstGeom prst="rect">
+            <a:avLst/>
+          </a:prstGeom>
+          <a:noFill/>
+        </p:spPr>
+        <p:txBody>
+          <a:bodyPr wrap="square" anchor="ctr">
+            <a:spAutoFit/>
+          </a:bodyPr>
+          <a:lstStyle/>
+          <a:p>
+            <a:pPr algn="ctr">
+              <a:spcAft>
+                <a:spcPts val="600"/>
+              </a:spcAft>
+            </a:pPr>
+            <a:r>
+              <a:rPr sz="1900" b="1">
+                <a:solidFill>
+                  <a:srgbClr val="6D2E46"/>
+                </a:solidFill>
+                <a:latin typeface="Calibri"/>
+              </a:rPr>
+              <a:t>Volver</a:t>
+            </a:r>
+          </a:p>
+          <a:p>
+            <a:pPr algn="ctr">
+              <a:spcAft>
+                <a:spcPts val="600"/>
+              </a:spcAft>
+            </a:pPr>
+            <a:r>
+              <a:rPr sz="1400" b="0">
+                <a:solidFill>
+                  <a:srgbClr val="6F645B"/>
+                </a:solidFill>
+                <a:latin typeface="Calibri"/>
+              </a:rPr>
+              <a:t>a la lista</a:t>
+            </a:r>
+          </a:p>
+        </p:txBody>
+      </p:sp>
+      <p:sp>
+        <p:nvSpPr>
+          <p:cNvPr id="21" name="TextBox 20"/>
+          <p:cNvSpPr txBox="1"/>
+          <p:nvPr/>
+        </p:nvSpPr>
+        <p:spPr>
+          <a:xfrm>
+            <a:off x="868680" y="5394960"/>
+            <a:ext cx="10424160" cy="731520"/>
           </a:xfrm>
           <a:prstGeom prst="rect">
             <a:avLst/>
@@ -6817,155 +7750,13 @@
               </a:spcAft>
             </a:pPr>
             <a:r>
-              <a:rPr sz="2000" b="1">
-                <a:solidFill>
-                  <a:srgbClr val="C84B31"/>
-                </a:solidFill>
-                <a:latin typeface="Calibri"/>
-              </a:rPr>
-              <a:t>LABORATORIO DE HOY</a:t>
-            </a:r>
-          </a:p>
-        </p:txBody>
-      </p:sp>
-      <p:sp>
-        <p:nvSpPr>
-          <p:cNvPr id="5" name="TextBox 4"/>
-          <p:cNvSpPr txBox="1"/>
-          <p:nvPr/>
-        </p:nvSpPr>
-        <p:spPr>
-          <a:xfrm>
-            <a:off x="1051560" y="1463040"/>
-            <a:ext cx="10058400" cy="914400"/>
-          </a:xfrm>
-          <a:prstGeom prst="rect">
-            <a:avLst/>
-          </a:prstGeom>
-          <a:noFill/>
-        </p:spPr>
-        <p:txBody>
-          <a:bodyPr wrap="square" anchor="t">
-            <a:spAutoFit/>
-          </a:bodyPr>
-          <a:lstStyle/>
-          <a:p>
-            <a:pPr algn="l">
-              <a:spcAft>
-                <a:spcPts val="600"/>
-              </a:spcAft>
-            </a:pPr>
-            <a:r>
-              <a:rPr sz="3400" b="1">
-                <a:solidFill>
-                  <a:srgbClr val="6D2E46"/>
-                </a:solidFill>
-                <a:latin typeface="Calibri"/>
-              </a:rPr>
-              <a:t>Laboratorio 2 — Prototipo navegable</a:t>
-            </a:r>
-          </a:p>
-        </p:txBody>
-      </p:sp>
-      <p:sp>
-        <p:nvSpPr>
-          <p:cNvPr id="6" name="TextBox 5"/>
-          <p:cNvSpPr txBox="1"/>
-          <p:nvPr/>
-        </p:nvSpPr>
-        <p:spPr>
-          <a:xfrm>
-            <a:off x="1097280" y="2606040"/>
-            <a:ext cx="9875520" cy="3383280"/>
-          </a:xfrm>
-          <a:prstGeom prst="rect">
-            <a:avLst/>
-          </a:prstGeom>
-          <a:noFill/>
-        </p:spPr>
-        <p:txBody>
-          <a:bodyPr wrap="square">
-            <a:spAutoFit/>
-          </a:bodyPr>
-          <a:lstStyle/>
-          <a:p>
-            <a:pPr>
-              <a:spcAft>
-                <a:spcPts val="1500"/>
-              </a:spcAft>
-            </a:pPr>
-            <a:r>
-              <a:rPr sz="2300">
+              <a:rPr sz="1700" b="0">
                 <a:solidFill>
                   <a:srgbClr val="2B2B2B"/>
                 </a:solidFill>
                 <a:latin typeface="Calibri"/>
               </a:rPr>
-              <a:t>•  Guarda un checkpoint antes de refinar</a:t>
-            </a:r>
-          </a:p>
-          <a:p>
-            <a:pPr>
-              <a:spcAft>
-                <a:spcPts val="1500"/>
-              </a:spcAft>
-            </a:pPr>
-            <a:r>
-              <a:rPr sz="2300">
-                <a:solidFill>
-                  <a:srgbClr val="2B2B2B"/>
-                </a:solidFill>
-                <a:latin typeface="Calibri"/>
-              </a:rPr>
-              <a:t>•  Agrega el filtro por categoría (con "Todas")</a:t>
-            </a:r>
-          </a:p>
-          <a:p>
-            <a:pPr>
-              <a:spcAft>
-                <a:spcPts val="1500"/>
-              </a:spcAft>
-            </a:pPr>
-            <a:r>
-              <a:rPr sz="2300">
-                <a:solidFill>
-                  <a:srgbClr val="2B2B2B"/>
-                </a:solidFill>
-                <a:latin typeface="Calibri"/>
-              </a:rPr>
-              <a:t>•  Agrega la vista de detalle con botón "Volver"</a:t>
-            </a:r>
-          </a:p>
-          <a:p>
-            <a:pPr>
-              <a:spcAft>
-                <a:spcPts val="1500"/>
-              </a:spcAft>
-            </a:pPr>
-            <a:r>
-              <a:rPr sz="2300">
-                <a:solidFill>
-                  <a:srgbClr val="2B2B2B"/>
-                </a:solidFill>
-                <a:latin typeface="Calibri"/>
-              </a:rPr>
-              <a:t>•  Aplica tu propia identidad visual (Tarea 2)</a:t>
-            </a:r>
-          </a:p>
-          <a:p>
-            <a:pPr>
-              <a:spcAft>
-                <a:spcPts val="1500"/>
-              </a:spcAft>
-            </a:pPr>
-            <a:r>
-              <a:rPr sz="2300">
-                <a:solidFill>
-                  <a:srgbClr val="2B2B2B"/>
-                </a:solidFill>
-                <a:latin typeface="Calibri"/>
-              </a:rPr>
-              <a:t>•  Pule un detalle con el modo de anotación</a:t>
+              <a:t>Este mismo patrón lo usarás en casi todas las apps: una pantalla que muestra muchos elementos y otra que muestra uno a fondo.</a:t>
             </a:r>
           </a:p>
         </p:txBody>

</xml_diff>